<commit_message>
JCPA appendix integration into manuscript
</commit_message>
<xml_diff>
--- a/JCPA_figures_FINAL.pptx
+++ b/JCPA_figures_FINAL.pptx
@@ -6052,7 +6052,7 @@
                     <a:lstStyle/>
                     <a:p>
                       <a:r>
-                        <a:t>-0.013 to -0.001</a:t>
+                        <a:t>-0.014 to -0.001</a:t>
                       </a:r>
                     </a:p>
                   </a:txBody>
@@ -9231,31 +9231,31 @@
                     <a:lstStyle/>
                     <a:p>
                       <a:r>
-                        <a:t>0.029300435978957</a:t>
-                      </a:r>
-                    </a:p>
-                  </a:txBody>
-                  <a:tcPr/>
-                </a:tc>
-                <a:tc>
-                  <a:txBody>
-                    <a:bodyPr/>
-                    <a:lstStyle/>
-                    <a:p>
-                      <a:r>
-                        <a:t>0.1839369039357427</a:t>
-                      </a:r>
-                    </a:p>
-                  </a:txBody>
-                  <a:tcPr/>
-                </a:tc>
-                <a:tc>
-                  <a:txBody>
-                    <a:bodyPr/>
-                    <a:lstStyle/>
-                    <a:p>
-                      <a:r>
-                        <a:t>-0.0106632246883388</a:t>
+                        <a:t>0.0293004359789378</a:t>
+                      </a:r>
+                    </a:p>
+                  </a:txBody>
+                  <a:tcPr/>
+                </a:tc>
+                <a:tc>
+                  <a:txBody>
+                    <a:bodyPr/>
+                    <a:lstStyle/>
+                    <a:p>
+                      <a:r>
+                        <a:t>0.1839369029359153</a:t>
+                      </a:r>
+                    </a:p>
+                  </a:txBody>
+                  <a:tcPr/>
+                </a:tc>
+                <a:tc>
+                  <a:txBody>
+                    <a:bodyPr/>
+                    <a:lstStyle/>
+                    <a:p>
+                      <a:r>
+                        <a:t>-0.0106632202853943</a:t>
                       </a:r>
                     </a:p>
                   </a:txBody>
@@ -9305,31 +9305,31 @@
                     <a:lstStyle/>
                     <a:p>
                       <a:r>
-                        <a:t>0.0097976486916118</a:t>
-                      </a:r>
-                    </a:p>
-                  </a:txBody>
-                  <a:tcPr/>
-                </a:tc>
-                <a:tc>
-                  <a:txBody>
-                    <a:bodyPr/>
-                    <a:lstStyle/>
-                    <a:p>
-                      <a:r>
-                        <a:t>0.0816468772883595</a:t>
-                      </a:r>
-                    </a:p>
-                  </a:txBody>
-                  <a:tcPr/>
-                </a:tc>
-                <a:tc>
-                  <a:txBody>
-                    <a:bodyPr/>
-                    <a:lstStyle/>
-                    <a:p>
-                      <a:r>
-                        <a:t>0.0551197205542313</a:t>
+                        <a:t>0.0097976486915868</a:t>
+                      </a:r>
+                    </a:p>
+                  </a:txBody>
+                  <a:tcPr/>
+                </a:tc>
+                <a:tc>
+                  <a:txBody>
+                    <a:bodyPr/>
+                    <a:lstStyle/>
+                    <a:p>
+                      <a:r>
+                        <a:t>0.0816468760361608</a:t>
+                      </a:r>
+                    </a:p>
+                  </a:txBody>
+                  <a:tcPr/>
+                </a:tc>
+                <a:tc>
+                  <a:txBody>
+                    <a:bodyPr/>
+                    <a:lstStyle/>
+                    <a:p>
+                      <a:r>
+                        <a:t>0.0551197222469218</a:t>
                       </a:r>
                     </a:p>
                   </a:txBody>
@@ -9379,31 +9379,31 @@
                     <a:lstStyle/>
                     <a:p>
                       <a:r>
-                        <a:t>0.0884818531209874</a:t>
-                      </a:r>
-                    </a:p>
-                  </a:txBody>
-                  <a:tcPr/>
-                </a:tc>
-                <a:tc>
-                  <a:txBody>
-                    <a:bodyPr/>
-                    <a:lstStyle/>
-                    <a:p>
-                      <a:r>
-                        <a:t>0.2043825464261744</a:t>
-                      </a:r>
-                    </a:p>
-                  </a:txBody>
-                  <a:tcPr/>
-                </a:tc>
-                <a:tc>
-                  <a:txBody>
-                    <a:bodyPr/>
-                    <a:lstStyle/>
-                    <a:p>
-                      <a:r>
-                        <a:t>-0.1279506017217466</a:t>
+                        <a:t>0.0884818531208004</a:t>
+                      </a:r>
+                    </a:p>
+                  </a:txBody>
+                  <a:tcPr/>
+                </a:tc>
+                <a:tc>
+                  <a:txBody>
+                    <a:bodyPr/>
+                    <a:lstStyle/>
+                    <a:p>
+                      <a:r>
+                        <a:t>0.2043826907729224</a:t>
+                      </a:r>
+                    </a:p>
+                  </a:txBody>
+                  <a:tcPr/>
+                </a:tc>
+                <a:tc>
+                  <a:txBody>
+                    <a:bodyPr/>
+                    <a:lstStyle/>
+                    <a:p>
+                      <a:r>
+                        <a:t>-0.1279509738692234</a:t>
                       </a:r>
                     </a:p>
                   </a:txBody>
@@ -9453,31 +9453,31 @@
                     <a:lstStyle/>
                     <a:p>
                       <a:r>
-                        <a:t>0.0593407198567986</a:t>
-                      </a:r>
-                    </a:p>
-                  </a:txBody>
-                  <a:tcPr/>
-                </a:tc>
-                <a:tc>
-                  <a:txBody>
-                    <a:bodyPr/>
-                    <a:lstStyle/>
-                    <a:p>
-                      <a:r>
-                        <a:t>0.164491604408235</a:t>
-                      </a:r>
-                    </a:p>
-                  </a:txBody>
-                  <a:tcPr/>
-                </a:tc>
-                <a:tc>
-                  <a:txBody>
-                    <a:bodyPr/>
-                    <a:lstStyle/>
-                    <a:p>
-                      <a:r>
-                        <a:t>-0.1516691457422756</a:t>
+                        <a:t>0.0593407198568021</a:t>
+                      </a:r>
+                    </a:p>
+                  </a:txBody>
+                  <a:tcPr/>
+                </a:tc>
+                <a:tc>
+                  <a:txBody>
+                    <a:bodyPr/>
+                    <a:lstStyle/>
+                    <a:p>
+                      <a:r>
+                        <a:t>0.1644916020423305</a:t>
+                      </a:r>
+                    </a:p>
+                  </a:txBody>
+                  <a:tcPr/>
+                </a:tc>
+                <a:tc>
+                  <a:txBody>
+                    <a:bodyPr/>
+                    <a:lstStyle/>
+                    <a:p>
+                      <a:r>
+                        <a:t>-0.1516691449521056</a:t>
                       </a:r>
                     </a:p>
                   </a:txBody>
@@ -9527,31 +9527,31 @@
                     <a:lstStyle/>
                     <a:p>
                       <a:r>
-                        <a:t>0.0444060903046035</a:t>
-                      </a:r>
-                    </a:p>
-                  </a:txBody>
-                  <a:tcPr/>
-                </a:tc>
-                <a:tc>
-                  <a:txBody>
-                    <a:bodyPr/>
-                    <a:lstStyle/>
-                    <a:p>
-                      <a:r>
-                        <a:t>0.1480735301319032</a:t>
-                      </a:r>
-                    </a:p>
-                  </a:txBody>
-                  <a:tcPr/>
-                </a:tc>
-                <a:tc>
-                  <a:txBody>
-                    <a:bodyPr/>
-                    <a:lstStyle/>
-                    <a:p>
-                      <a:r>
-                        <a:t>0.0831437221720144</a:t>
+                        <a:t>0.0444060903046119</a:t>
+                      </a:r>
+                    </a:p>
+                  </a:txBody>
+                  <a:tcPr/>
+                </a:tc>
+                <a:tc>
+                  <a:txBody>
+                    <a:bodyPr/>
+                    <a:lstStyle/>
+                    <a:p>
+                      <a:r>
+                        <a:t>0.148073524583365</a:t>
+                      </a:r>
+                    </a:p>
+                  </a:txBody>
+                  <a:tcPr/>
+                </a:tc>
+                <a:tc>
+                  <a:txBody>
+                    <a:bodyPr/>
+                    <a:lstStyle/>
+                    <a:p>
+                      <a:r>
+                        <a:t>0.0831437141637636</a:t>
                       </a:r>
                     </a:p>
                   </a:txBody>
@@ -9601,31 +9601,31 @@
                     <a:lstStyle/>
                     <a:p>
                       <a:r>
-                        <a:t>0.1444174894492097</a:t>
-                      </a:r>
-                    </a:p>
-                  </a:txBody>
-                  <a:tcPr/>
-                </a:tc>
-                <a:tc>
-                  <a:txBody>
-                    <a:bodyPr/>
-                    <a:lstStyle/>
-                    <a:p>
-                      <a:r>
-                        <a:t>0.3036512375095741</a:t>
-                      </a:r>
-                    </a:p>
-                  </a:txBody>
-                  <a:tcPr/>
-                </a:tc>
-                <a:tc>
-                  <a:txBody>
-                    <a:bodyPr/>
-                    <a:lstStyle/>
-                    <a:p>
-                      <a:r>
-                        <a:t>-0.2680256930368754</a:t>
+                        <a:t>0.1444174894492124</a:t>
+                      </a:r>
+                    </a:p>
+                  </a:txBody>
+                  <a:tcPr/>
+                </a:tc>
+                <a:tc>
+                  <a:txBody>
+                    <a:bodyPr/>
+                    <a:lstStyle/>
+                    <a:p>
+                      <a:r>
+                        <a:t>0.3036511289006508</a:t>
+                      </a:r>
+                    </a:p>
+                  </a:txBody>
+                  <a:tcPr/>
+                </a:tc>
+                <a:tc>
+                  <a:txBody>
+                    <a:bodyPr/>
+                    <a:lstStyle/>
+                    <a:p>
+                      <a:r>
+                        <a:t>-0.2680255705173741</a:t>
                       </a:r>
                     </a:p>
                   </a:txBody>
@@ -9675,31 +9675,31 @@
                     <a:lstStyle/>
                     <a:p>
                       <a:r>
-                        <a:t>0.0489068465462905</a:t>
-                      </a:r>
-                    </a:p>
-                  </a:txBody>
-                  <a:tcPr/>
-                </a:tc>
-                <a:tc>
-                  <a:txBody>
-                    <a:bodyPr/>
-                    <a:lstStyle/>
-                    <a:p>
-                      <a:r>
-                        <a:t>0.2571351516004428</a:t>
-                      </a:r>
-                    </a:p>
-                  </a:txBody>
-                  <a:tcPr/>
-                </a:tc>
-                <a:tc>
-                  <a:txBody>
-                    <a:bodyPr/>
-                    <a:lstStyle/>
-                    <a:p>
-                      <a:r>
-                        <a:t>-0.1909625167259772</a:t>
+                        <a:t>0.0489068465462831</a:t>
+                      </a:r>
+                    </a:p>
+                  </a:txBody>
+                  <a:tcPr/>
+                </a:tc>
+                <a:tc>
+                  <a:txBody>
+                    <a:bodyPr/>
+                    <a:lstStyle/>
+                    <a:p>
+                      <a:r>
+                        <a:t>0.2571351506549926</a:t>
+                      </a:r>
+                    </a:p>
+                  </a:txBody>
+                  <a:tcPr/>
+                </a:tc>
+                <a:tc>
+                  <a:txBody>
+                    <a:bodyPr/>
+                    <a:lstStyle/>
+                    <a:p>
+                      <a:r>
+                        <a:t>-0.1909625137928648</a:t>
                       </a:r>
                     </a:p>
                   </a:txBody>
@@ -9749,31 +9749,31 @@
                     <a:lstStyle/>
                     <a:p>
                       <a:r>
-                        <a:t>0.0043825333785589</a:t>
-                      </a:r>
-                    </a:p>
-                  </a:txBody>
-                  <a:tcPr/>
-                </a:tc>
-                <a:tc>
-                  <a:txBody>
-                    <a:bodyPr/>
-                    <a:lstStyle/>
-                    <a:p>
-                      <a:r>
-                        <a:t>0.1800522918063515</a:t>
-                      </a:r>
-                    </a:p>
-                  </a:txBody>
-                  <a:tcPr/>
-                </a:tc>
-                <a:tc>
-                  <a:txBody>
-                    <a:bodyPr/>
-                    <a:lstStyle/>
-                    <a:p>
-                      <a:r>
-                        <a:t>-0.0984116620871223</a:t>
+                        <a:t>0.004382533378559</a:t>
+                      </a:r>
+                    </a:p>
+                  </a:txBody>
+                  <a:tcPr/>
+                </a:tc>
+                <a:tc>
+                  <a:txBody>
+                    <a:bodyPr/>
+                    <a:lstStyle/>
+                    <a:p>
+                      <a:r>
+                        <a:t>0.1800522917924872</a:t>
+                      </a:r>
+                    </a:p>
+                  </a:txBody>
+                  <a:tcPr/>
+                </a:tc>
+                <a:tc>
+                  <a:txBody>
+                    <a:bodyPr/>
+                    <a:lstStyle/>
+                    <a:p>
+                      <a:r>
+                        <a:t>-0.098411662199711</a:t>
                       </a:r>
                     </a:p>
                   </a:txBody>
@@ -9823,31 +9823,31 @@
                     <a:lstStyle/>
                     <a:p>
                       <a:r>
-                        <a:t>0.1826943753700612</a:t>
-                      </a:r>
-                    </a:p>
-                  </a:txBody>
-                  <a:tcPr/>
-                </a:tc>
-                <a:tc>
-                  <a:txBody>
-                    <a:bodyPr/>
-                    <a:lstStyle/>
-                    <a:p>
-                      <a:r>
-                        <a:t>0.2488059137391605</a:t>
-                      </a:r>
-                    </a:p>
-                  </a:txBody>
-                  <a:tcPr/>
-                </a:tc>
-                <a:tc>
-                  <a:txBody>
-                    <a:bodyPr/>
-                    <a:lstStyle/>
-                    <a:p>
-                      <a:r>
-                        <a:t>-0.1367370322694726</a:t>
+                        <a:t>0.1826943753700668</a:t>
+                      </a:r>
+                    </a:p>
+                  </a:txBody>
+                  <a:tcPr/>
+                </a:tc>
+                <a:tc>
+                  <a:txBody>
+                    <a:bodyPr/>
+                    <a:lstStyle/>
+                    <a:p>
+                      <a:r>
+                        <a:t>0.2488059139201824</a:t>
+                      </a:r>
+                    </a:p>
+                  </a:txBody>
+                  <a:tcPr/>
+                </a:tc>
+                <a:tc>
+                  <a:txBody>
+                    <a:bodyPr/>
+                    <a:lstStyle/>
+                    <a:p>
+                      <a:r>
+                        <a:t>-0.1367370317019828</a:t>
                       </a:r>
                     </a:p>
                   </a:txBody>
@@ -9897,31 +9897,31 @@
                     <a:lstStyle/>
                     <a:p>
                       <a:r>
-                        <a:t>0.0168998085544814</a:t>
-                      </a:r>
-                    </a:p>
-                  </a:txBody>
-                  <a:tcPr/>
-                </a:tc>
-                <a:tc>
-                  <a:txBody>
-                    <a:bodyPr/>
-                    <a:lstStyle/>
-                    <a:p>
-                      <a:r>
-                        <a:t>0.1182144357751331</a:t>
-                      </a:r>
-                    </a:p>
-                  </a:txBody>
-                  <a:tcPr/>
-                </a:tc>
-                <a:tc>
-                  <a:txBody>
-                    <a:bodyPr/>
-                    <a:lstStyle/>
-                    <a:p>
-                      <a:r>
-                        <a:t>-0.0265778278315405</a:t>
+                        <a:t>0.0168998085544957</a:t>
+                      </a:r>
+                    </a:p>
+                  </a:txBody>
+                  <a:tcPr/>
+                </a:tc>
+                <a:tc>
+                  <a:txBody>
+                    <a:bodyPr/>
+                    <a:lstStyle/>
+                    <a:p>
+                      <a:r>
+                        <a:t>0.1182144350993184</a:t>
+                      </a:r>
+                    </a:p>
+                  </a:txBody>
+                  <a:tcPr/>
+                </a:tc>
+                <a:tc>
+                  <a:txBody>
+                    <a:bodyPr/>
+                    <a:lstStyle/>
+                    <a:p>
+                      <a:r>
+                        <a:t>-0.0265778280351051</a:t>
                       </a:r>
                     </a:p>
                   </a:txBody>

</xml_diff>

<commit_message>
JCPA micro-fix: neutral wording + readable tables
</commit_message>
<xml_diff>
--- a/JCPA_figures_FINAL.pptx
+++ b/JCPA_figures_FINAL.pptx
@@ -9231,31 +9231,31 @@
                     <a:lstStyle/>
                     <a:p>
                       <a:r>
-                        <a:t>0.0293004359789378</a:t>
-                      </a:r>
-                    </a:p>
-                  </a:txBody>
-                  <a:tcPr/>
-                </a:tc>
-                <a:tc>
-                  <a:txBody>
-                    <a:bodyPr/>
-                    <a:lstStyle/>
-                    <a:p>
-                      <a:r>
-                        <a:t>0.1839369029359153</a:t>
-                      </a:r>
-                    </a:p>
-                  </a:txBody>
-                  <a:tcPr/>
-                </a:tc>
-                <a:tc>
-                  <a:txBody>
-                    <a:bodyPr/>
-                    <a:lstStyle/>
-                    <a:p>
-                      <a:r>
-                        <a:t>-0.0106632202853943</a:t>
+                        <a:t>0.029</a:t>
+                      </a:r>
+                    </a:p>
+                  </a:txBody>
+                  <a:tcPr/>
+                </a:tc>
+                <a:tc>
+                  <a:txBody>
+                    <a:bodyPr/>
+                    <a:lstStyle/>
+                    <a:p>
+                      <a:r>
+                        <a:t>0.184</a:t>
+                      </a:r>
+                    </a:p>
+                  </a:txBody>
+                  <a:tcPr/>
+                </a:tc>
+                <a:tc>
+                  <a:txBody>
+                    <a:bodyPr/>
+                    <a:lstStyle/>
+                    <a:p>
+                      <a:r>
+                        <a:t>-0.011</a:t>
                       </a:r>
                     </a:p>
                   </a:txBody>
@@ -9305,43 +9305,43 @@
                     <a:lstStyle/>
                     <a:p>
                       <a:r>
-                        <a:t>0.0097976486915868</a:t>
-                      </a:r>
-                    </a:p>
-                  </a:txBody>
-                  <a:tcPr/>
-                </a:tc>
-                <a:tc>
-                  <a:txBody>
-                    <a:bodyPr/>
-                    <a:lstStyle/>
-                    <a:p>
-                      <a:r>
-                        <a:t>0.0816468760361608</a:t>
-                      </a:r>
-                    </a:p>
-                  </a:txBody>
-                  <a:tcPr/>
-                </a:tc>
-                <a:tc>
-                  <a:txBody>
-                    <a:bodyPr/>
-                    <a:lstStyle/>
-                    <a:p>
-                      <a:r>
-                        <a:t>0.0551197222469218</a:t>
-                      </a:r>
-                    </a:p>
-                  </a:txBody>
-                  <a:tcPr/>
-                </a:tc>
-                <a:tc>
-                  <a:txBody>
-                    <a:bodyPr/>
-                    <a:lstStyle/>
-                    <a:p>
-                      <a:r>
-                        <a:t>0.3333333333333333</a:t>
+                        <a:t>0.01</a:t>
+                      </a:r>
+                    </a:p>
+                  </a:txBody>
+                  <a:tcPr/>
+                </a:tc>
+                <a:tc>
+                  <a:txBody>
+                    <a:bodyPr/>
+                    <a:lstStyle/>
+                    <a:p>
+                      <a:r>
+                        <a:t>0.082</a:t>
+                      </a:r>
+                    </a:p>
+                  </a:txBody>
+                  <a:tcPr/>
+                </a:tc>
+                <a:tc>
+                  <a:txBody>
+                    <a:bodyPr/>
+                    <a:lstStyle/>
+                    <a:p>
+                      <a:r>
+                        <a:t>0.055</a:t>
+                      </a:r>
+                    </a:p>
+                  </a:txBody>
+                  <a:tcPr/>
+                </a:tc>
+                <a:tc>
+                  <a:txBody>
+                    <a:bodyPr/>
+                    <a:lstStyle/>
+                    <a:p>
+                      <a:r>
+                        <a:t>0.333</a:t>
                       </a:r>
                     </a:p>
                   </a:txBody>
@@ -9379,43 +9379,43 @@
                     <a:lstStyle/>
                     <a:p>
                       <a:r>
-                        <a:t>0.0884818531208004</a:t>
-                      </a:r>
-                    </a:p>
-                  </a:txBody>
-                  <a:tcPr/>
-                </a:tc>
-                <a:tc>
-                  <a:txBody>
-                    <a:bodyPr/>
-                    <a:lstStyle/>
-                    <a:p>
-                      <a:r>
-                        <a:t>0.2043826907729224</a:t>
-                      </a:r>
-                    </a:p>
-                  </a:txBody>
-                  <a:tcPr/>
-                </a:tc>
-                <a:tc>
-                  <a:txBody>
-                    <a:bodyPr/>
-                    <a:lstStyle/>
-                    <a:p>
-                      <a:r>
-                        <a:t>-0.1279509738692234</a:t>
-                      </a:r>
-                    </a:p>
-                  </a:txBody>
-                  <a:tcPr/>
-                </a:tc>
-                <a:tc>
-                  <a:txBody>
-                    <a:bodyPr/>
-                    <a:lstStyle/>
-                    <a:p>
-                      <a:r>
-                        <a:t>0.7142857142857143</a:t>
+                        <a:t>0.088</a:t>
+                      </a:r>
+                    </a:p>
+                  </a:txBody>
+                  <a:tcPr/>
+                </a:tc>
+                <a:tc>
+                  <a:txBody>
+                    <a:bodyPr/>
+                    <a:lstStyle/>
+                    <a:p>
+                      <a:r>
+                        <a:t>0.204</a:t>
+                      </a:r>
+                    </a:p>
+                  </a:txBody>
+                  <a:tcPr/>
+                </a:tc>
+                <a:tc>
+                  <a:txBody>
+                    <a:bodyPr/>
+                    <a:lstStyle/>
+                    <a:p>
+                      <a:r>
+                        <a:t>-0.128</a:t>
+                      </a:r>
+                    </a:p>
+                  </a:txBody>
+                  <a:tcPr/>
+                </a:tc>
+                <a:tc>
+                  <a:txBody>
+                    <a:bodyPr/>
+                    <a:lstStyle/>
+                    <a:p>
+                      <a:r>
+                        <a:t>0.714</a:t>
                       </a:r>
                     </a:p>
                   </a:txBody>
@@ -9453,31 +9453,31 @@
                     <a:lstStyle/>
                     <a:p>
                       <a:r>
-                        <a:t>0.0593407198568021</a:t>
-                      </a:r>
-                    </a:p>
-                  </a:txBody>
-                  <a:tcPr/>
-                </a:tc>
-                <a:tc>
-                  <a:txBody>
-                    <a:bodyPr/>
-                    <a:lstStyle/>
-                    <a:p>
-                      <a:r>
-                        <a:t>0.1644916020423305</a:t>
-                      </a:r>
-                    </a:p>
-                  </a:txBody>
-                  <a:tcPr/>
-                </a:tc>
-                <a:tc>
-                  <a:txBody>
-                    <a:bodyPr/>
-                    <a:lstStyle/>
-                    <a:p>
-                      <a:r>
-                        <a:t>-0.1516691449521056</a:t>
+                        <a:t>0.059</a:t>
+                      </a:r>
+                    </a:p>
+                  </a:txBody>
+                  <a:tcPr/>
+                </a:tc>
+                <a:tc>
+                  <a:txBody>
+                    <a:bodyPr/>
+                    <a:lstStyle/>
+                    <a:p>
+                      <a:r>
+                        <a:t>0.164</a:t>
+                      </a:r>
+                    </a:p>
+                  </a:txBody>
+                  <a:tcPr/>
+                </a:tc>
+                <a:tc>
+                  <a:txBody>
+                    <a:bodyPr/>
+                    <a:lstStyle/>
+                    <a:p>
+                      <a:r>
+                        <a:t>-0.152</a:t>
                       </a:r>
                     </a:p>
                   </a:txBody>
@@ -9527,31 +9527,31 @@
                     <a:lstStyle/>
                     <a:p>
                       <a:r>
-                        <a:t>0.0444060903046119</a:t>
-                      </a:r>
-                    </a:p>
-                  </a:txBody>
-                  <a:tcPr/>
-                </a:tc>
-                <a:tc>
-                  <a:txBody>
-                    <a:bodyPr/>
-                    <a:lstStyle/>
-                    <a:p>
-                      <a:r>
-                        <a:t>0.148073524583365</a:t>
-                      </a:r>
-                    </a:p>
-                  </a:txBody>
-                  <a:tcPr/>
-                </a:tc>
-                <a:tc>
-                  <a:txBody>
-                    <a:bodyPr/>
-                    <a:lstStyle/>
-                    <a:p>
-                      <a:r>
-                        <a:t>0.0831437141637636</a:t>
+                        <a:t>0.044</a:t>
+                      </a:r>
+                    </a:p>
+                  </a:txBody>
+                  <a:tcPr/>
+                </a:tc>
+                <a:tc>
+                  <a:txBody>
+                    <a:bodyPr/>
+                    <a:lstStyle/>
+                    <a:p>
+                      <a:r>
+                        <a:t>0.148</a:t>
+                      </a:r>
+                    </a:p>
+                  </a:txBody>
+                  <a:tcPr/>
+                </a:tc>
+                <a:tc>
+                  <a:txBody>
+                    <a:bodyPr/>
+                    <a:lstStyle/>
+                    <a:p>
+                      <a:r>
+                        <a:t>0.083</a:t>
                       </a:r>
                     </a:p>
                   </a:txBody>
@@ -9601,43 +9601,43 @@
                     <a:lstStyle/>
                     <a:p>
                       <a:r>
-                        <a:t>0.1444174894492124</a:t>
-                      </a:r>
-                    </a:p>
-                  </a:txBody>
-                  <a:tcPr/>
-                </a:tc>
-                <a:tc>
-                  <a:txBody>
-                    <a:bodyPr/>
-                    <a:lstStyle/>
-                    <a:p>
-                      <a:r>
-                        <a:t>0.3036511289006508</a:t>
-                      </a:r>
-                    </a:p>
-                  </a:txBody>
-                  <a:tcPr/>
-                </a:tc>
-                <a:tc>
-                  <a:txBody>
-                    <a:bodyPr/>
-                    <a:lstStyle/>
-                    <a:p>
-                      <a:r>
-                        <a:t>-0.2680255705173741</a:t>
-                      </a:r>
-                    </a:p>
-                  </a:txBody>
-                  <a:tcPr/>
-                </a:tc>
-                <a:tc>
-                  <a:txBody>
-                    <a:bodyPr/>
-                    <a:lstStyle/>
-                    <a:p>
-                      <a:r>
-                        <a:t>0.5625</a:t>
+                        <a:t>0.144</a:t>
+                      </a:r>
+                    </a:p>
+                  </a:txBody>
+                  <a:tcPr/>
+                </a:tc>
+                <a:tc>
+                  <a:txBody>
+                    <a:bodyPr/>
+                    <a:lstStyle/>
+                    <a:p>
+                      <a:r>
+                        <a:t>0.304</a:t>
+                      </a:r>
+                    </a:p>
+                  </a:txBody>
+                  <a:tcPr/>
+                </a:tc>
+                <a:tc>
+                  <a:txBody>
+                    <a:bodyPr/>
+                    <a:lstStyle/>
+                    <a:p>
+                      <a:r>
+                        <a:t>-0.268</a:t>
+                      </a:r>
+                    </a:p>
+                  </a:txBody>
+                  <a:tcPr/>
+                </a:tc>
+                <a:tc>
+                  <a:txBody>
+                    <a:bodyPr/>
+                    <a:lstStyle/>
+                    <a:p>
+                      <a:r>
+                        <a:t>0.562</a:t>
                       </a:r>
                     </a:p>
                   </a:txBody>
@@ -9675,43 +9675,43 @@
                     <a:lstStyle/>
                     <a:p>
                       <a:r>
-                        <a:t>0.0489068465462831</a:t>
-                      </a:r>
-                    </a:p>
-                  </a:txBody>
-                  <a:tcPr/>
-                </a:tc>
-                <a:tc>
-                  <a:txBody>
-                    <a:bodyPr/>
-                    <a:lstStyle/>
-                    <a:p>
-                      <a:r>
-                        <a:t>0.2571351506549926</a:t>
-                      </a:r>
-                    </a:p>
-                  </a:txBody>
-                  <a:tcPr/>
-                </a:tc>
-                <a:tc>
-                  <a:txBody>
-                    <a:bodyPr/>
-                    <a:lstStyle/>
-                    <a:p>
-                      <a:r>
-                        <a:t>-0.1909625137928648</a:t>
-                      </a:r>
-                    </a:p>
-                  </a:txBody>
-                  <a:tcPr/>
-                </a:tc>
-                <a:tc>
-                  <a:txBody>
-                    <a:bodyPr/>
-                    <a:lstStyle/>
-                    <a:p>
-                      <a:r>
-                        <a:t>0.2857142857142857</a:t>
+                        <a:t>0.049</a:t>
+                      </a:r>
+                    </a:p>
+                  </a:txBody>
+                  <a:tcPr/>
+                </a:tc>
+                <a:tc>
+                  <a:txBody>
+                    <a:bodyPr/>
+                    <a:lstStyle/>
+                    <a:p>
+                      <a:r>
+                        <a:t>0.257</a:t>
+                      </a:r>
+                    </a:p>
+                  </a:txBody>
+                  <a:tcPr/>
+                </a:tc>
+                <a:tc>
+                  <a:txBody>
+                    <a:bodyPr/>
+                    <a:lstStyle/>
+                    <a:p>
+                      <a:r>
+                        <a:t>-0.191</a:t>
+                      </a:r>
+                    </a:p>
+                  </a:txBody>
+                  <a:tcPr/>
+                </a:tc>
+                <a:tc>
+                  <a:txBody>
+                    <a:bodyPr/>
+                    <a:lstStyle/>
+                    <a:p>
+                      <a:r>
+                        <a:t>0.286</a:t>
                       </a:r>
                     </a:p>
                   </a:txBody>
@@ -9749,43 +9749,43 @@
                     <a:lstStyle/>
                     <a:p>
                       <a:r>
-                        <a:t>0.004382533378559</a:t>
-                      </a:r>
-                    </a:p>
-                  </a:txBody>
-                  <a:tcPr/>
-                </a:tc>
-                <a:tc>
-                  <a:txBody>
-                    <a:bodyPr/>
-                    <a:lstStyle/>
-                    <a:p>
-                      <a:r>
-                        <a:t>0.1800522917924872</a:t>
-                      </a:r>
-                    </a:p>
-                  </a:txBody>
-                  <a:tcPr/>
-                </a:tc>
-                <a:tc>
-                  <a:txBody>
-                    <a:bodyPr/>
-                    <a:lstStyle/>
-                    <a:p>
-                      <a:r>
-                        <a:t>-0.098411662199711</a:t>
-                      </a:r>
-                    </a:p>
-                  </a:txBody>
-                  <a:tcPr/>
-                </a:tc>
-                <a:tc>
-                  <a:txBody>
-                    <a:bodyPr/>
-                    <a:lstStyle/>
-                    <a:p>
-                      <a:r>
-                        <a:t>0.2631578947368421</a:t>
+                        <a:t>0.004</a:t>
+                      </a:r>
+                    </a:p>
+                  </a:txBody>
+                  <a:tcPr/>
+                </a:tc>
+                <a:tc>
+                  <a:txBody>
+                    <a:bodyPr/>
+                    <a:lstStyle/>
+                    <a:p>
+                      <a:r>
+                        <a:t>0.18</a:t>
+                      </a:r>
+                    </a:p>
+                  </a:txBody>
+                  <a:tcPr/>
+                </a:tc>
+                <a:tc>
+                  <a:txBody>
+                    <a:bodyPr/>
+                    <a:lstStyle/>
+                    <a:p>
+                      <a:r>
+                        <a:t>-0.098</a:t>
+                      </a:r>
+                    </a:p>
+                  </a:txBody>
+                  <a:tcPr/>
+                </a:tc>
+                <a:tc>
+                  <a:txBody>
+                    <a:bodyPr/>
+                    <a:lstStyle/>
+                    <a:p>
+                      <a:r>
+                        <a:t>0.263</a:t>
                       </a:r>
                     </a:p>
                   </a:txBody>
@@ -9823,43 +9823,43 @@
                     <a:lstStyle/>
                     <a:p>
                       <a:r>
-                        <a:t>0.1826943753700668</a:t>
-                      </a:r>
-                    </a:p>
-                  </a:txBody>
-                  <a:tcPr/>
-                </a:tc>
-                <a:tc>
-                  <a:txBody>
-                    <a:bodyPr/>
-                    <a:lstStyle/>
-                    <a:p>
-                      <a:r>
-                        <a:t>0.2488059139201824</a:t>
-                      </a:r>
-                    </a:p>
-                  </a:txBody>
-                  <a:tcPr/>
-                </a:tc>
-                <a:tc>
-                  <a:txBody>
-                    <a:bodyPr/>
-                    <a:lstStyle/>
-                    <a:p>
-                      <a:r>
-                        <a:t>-0.1367370317019828</a:t>
-                      </a:r>
-                    </a:p>
-                  </a:txBody>
-                  <a:tcPr/>
-                </a:tc>
-                <a:tc>
-                  <a:txBody>
-                    <a:bodyPr/>
-                    <a:lstStyle/>
-                    <a:p>
-                      <a:r>
-                        <a:t>0.8333333333333334</a:t>
+                        <a:t>0.183</a:t>
+                      </a:r>
+                    </a:p>
+                  </a:txBody>
+                  <a:tcPr/>
+                </a:tc>
+                <a:tc>
+                  <a:txBody>
+                    <a:bodyPr/>
+                    <a:lstStyle/>
+                    <a:p>
+                      <a:r>
+                        <a:t>0.249</a:t>
+                      </a:r>
+                    </a:p>
+                  </a:txBody>
+                  <a:tcPr/>
+                </a:tc>
+                <a:tc>
+                  <a:txBody>
+                    <a:bodyPr/>
+                    <a:lstStyle/>
+                    <a:p>
+                      <a:r>
+                        <a:t>-0.137</a:t>
+                      </a:r>
+                    </a:p>
+                  </a:txBody>
+                  <a:tcPr/>
+                </a:tc>
+                <a:tc>
+                  <a:txBody>
+                    <a:bodyPr/>
+                    <a:lstStyle/>
+                    <a:p>
+                      <a:r>
+                        <a:t>0.833</a:t>
                       </a:r>
                     </a:p>
                   </a:txBody>
@@ -9897,43 +9897,43 @@
                     <a:lstStyle/>
                     <a:p>
                       <a:r>
-                        <a:t>0.0168998085544957</a:t>
-                      </a:r>
-                    </a:p>
-                  </a:txBody>
-                  <a:tcPr/>
-                </a:tc>
-                <a:tc>
-                  <a:txBody>
-                    <a:bodyPr/>
-                    <a:lstStyle/>
-                    <a:p>
-                      <a:r>
-                        <a:t>0.1182144350993184</a:t>
-                      </a:r>
-                    </a:p>
-                  </a:txBody>
-                  <a:tcPr/>
-                </a:tc>
-                <a:tc>
-                  <a:txBody>
-                    <a:bodyPr/>
-                    <a:lstStyle/>
-                    <a:p>
-                      <a:r>
-                        <a:t>-0.0265778280351051</a:t>
-                      </a:r>
-                    </a:p>
-                  </a:txBody>
-                  <a:tcPr/>
-                </a:tc>
-                <a:tc>
-                  <a:txBody>
-                    <a:bodyPr/>
-                    <a:lstStyle/>
-                    <a:p>
-                      <a:r>
-                        <a:t>0.3043478260869565</a:t>
+                        <a:t>0.017</a:t>
+                      </a:r>
+                    </a:p>
+                  </a:txBody>
+                  <a:tcPr/>
+                </a:tc>
+                <a:tc>
+                  <a:txBody>
+                    <a:bodyPr/>
+                    <a:lstStyle/>
+                    <a:p>
+                      <a:r>
+                        <a:t>0.118</a:t>
+                      </a:r>
+                    </a:p>
+                  </a:txBody>
+                  <a:tcPr/>
+                </a:tc>
+                <a:tc>
+                  <a:txBody>
+                    <a:bodyPr/>
+                    <a:lstStyle/>
+                    <a:p>
+                      <a:r>
+                        <a:t>-0.027</a:t>
+                      </a:r>
+                    </a:p>
+                  </a:txBody>
+                  <a:tcPr/>
+                </a:tc>
+                <a:tc>
+                  <a:txBody>
+                    <a:bodyPr/>
+                    <a:lstStyle/>
+                    <a:p>
+                      <a:r>
+                        <a:t>0.304</a:t>
                       </a:r>
                     </a:p>
                   </a:txBody>

</xml_diff>